<commit_message>
Review 2 Material Added
</commit_message>
<xml_diff>
--- a/Review 1/PPT Review 1.pptx
+++ b/Review 1/PPT Review 1.pptx
@@ -229,7 +229,7 @@
           <a:p>
             <a:fld id="{9AF76926-F3C4-44FE-A7E3-2A27B1BEC30B}" type="datetimeFigureOut">
               <a:rPr lang="en-IN" smtClean="0"/>
-              <a:t>18-01-2026</a:t>
+              <a:t>22-02-2026</a:t>
             </a:fld>
             <a:endParaRPr lang="en-IN"/>
           </a:p>
@@ -945,7 +945,7 @@
           <a:p>
             <a:fld id="{5BCAD085-E8A6-8845-BD4E-CB4CCA059FC4}" type="datetimeFigureOut">
               <a:rPr lang="en-US" smtClean="0"/>
-              <a:t>1/18/2026</a:t>
+              <a:t>2/22/2026</a:t>
             </a:fld>
             <a:endParaRPr lang="en-US"/>
           </a:p>
@@ -1269,7 +1269,7 @@
           <a:p>
             <a:fld id="{5BCAD085-E8A6-8845-BD4E-CB4CCA059FC4}" type="datetimeFigureOut">
               <a:rPr lang="en-US" smtClean="0"/>
-              <a:t>1/18/2026</a:t>
+              <a:t>2/22/2026</a:t>
             </a:fld>
             <a:endParaRPr lang="en-US"/>
           </a:p>
@@ -1517,7 +1517,7 @@
           <a:p>
             <a:fld id="{5BCAD085-E8A6-8845-BD4E-CB4CCA059FC4}" type="datetimeFigureOut">
               <a:rPr lang="en-US" smtClean="0"/>
-              <a:t>1/18/2026</a:t>
+              <a:t>2/22/2026</a:t>
             </a:fld>
             <a:endParaRPr lang="en-US"/>
           </a:p>
@@ -1856,7 +1856,7 @@
           <a:p>
             <a:fld id="{5BCAD085-E8A6-8845-BD4E-CB4CCA059FC4}" type="datetimeFigureOut">
               <a:rPr lang="en-US" smtClean="0"/>
-              <a:t>1/18/2026</a:t>
+              <a:t>2/22/2026</a:t>
             </a:fld>
             <a:endParaRPr lang="en-US"/>
           </a:p>
@@ -2203,7 +2203,7 @@
           <a:p>
             <a:fld id="{5BCAD085-E8A6-8845-BD4E-CB4CCA059FC4}" type="datetimeFigureOut">
               <a:rPr lang="en-US" smtClean="0"/>
-              <a:t>1/18/2026</a:t>
+              <a:t>2/22/2026</a:t>
             </a:fld>
             <a:endParaRPr lang="en-US"/>
           </a:p>
@@ -2577,7 +2577,7 @@
           <a:p>
             <a:fld id="{5BCAD085-E8A6-8845-BD4E-CB4CCA059FC4}" type="datetimeFigureOut">
               <a:rPr lang="en-US" smtClean="0"/>
-              <a:t>1/18/2026</a:t>
+              <a:t>2/22/2026</a:t>
             </a:fld>
             <a:endParaRPr lang="en-US"/>
           </a:p>
@@ -3047,7 +3047,7 @@
           <a:p>
             <a:fld id="{5BCAD085-E8A6-8845-BD4E-CB4CCA059FC4}" type="datetimeFigureOut">
               <a:rPr lang="en-US" smtClean="0"/>
-              <a:t>1/18/2026</a:t>
+              <a:t>2/22/2026</a:t>
             </a:fld>
             <a:endParaRPr lang="en-US"/>
           </a:p>
@@ -3257,7 +3257,7 @@
           <a:p>
             <a:fld id="{5BCAD085-E8A6-8845-BD4E-CB4CCA059FC4}" type="datetimeFigureOut">
               <a:rPr lang="en-US" smtClean="0"/>
-              <a:t>1/18/2026</a:t>
+              <a:t>2/22/2026</a:t>
             </a:fld>
             <a:endParaRPr lang="en-US"/>
           </a:p>
@@ -3468,7 +3468,7 @@
           <a:p>
             <a:fld id="{5BCAD085-E8A6-8845-BD4E-CB4CCA059FC4}" type="datetimeFigureOut">
               <a:rPr lang="en-US" smtClean="0"/>
-              <a:t>1/18/2026</a:t>
+              <a:t>2/22/2026</a:t>
             </a:fld>
             <a:endParaRPr lang="en-US"/>
           </a:p>
@@ -3700,7 +3700,7 @@
           <a:p>
             <a:fld id="{5BCAD085-E8A6-8845-BD4E-CB4CCA059FC4}" type="datetimeFigureOut">
               <a:rPr lang="en-US" smtClean="0"/>
-              <a:t>1/18/2026</a:t>
+              <a:t>2/22/2026</a:t>
             </a:fld>
             <a:endParaRPr lang="en-US"/>
           </a:p>
@@ -3948,7 +3948,7 @@
           <a:p>
             <a:fld id="{5BCAD085-E8A6-8845-BD4E-CB4CCA059FC4}" type="datetimeFigureOut">
               <a:rPr lang="en-US" smtClean="0"/>
-              <a:t>1/18/2026</a:t>
+              <a:t>2/22/2026</a:t>
             </a:fld>
             <a:endParaRPr lang="en-US"/>
           </a:p>
@@ -4251,7 +4251,7 @@
           <a:p>
             <a:fld id="{5BCAD085-E8A6-8845-BD4E-CB4CCA059FC4}" type="datetimeFigureOut">
               <a:rPr lang="en-US" smtClean="0"/>
-              <a:t>1/18/2026</a:t>
+              <a:t>2/22/2026</a:t>
             </a:fld>
             <a:endParaRPr lang="en-US"/>
           </a:p>
@@ -4633,7 +4633,7 @@
           <a:p>
             <a:fld id="{5BCAD085-E8A6-8845-BD4E-CB4CCA059FC4}" type="datetimeFigureOut">
               <a:rPr lang="en-US" smtClean="0"/>
-              <a:t>1/18/2026</a:t>
+              <a:t>2/22/2026</a:t>
             </a:fld>
             <a:endParaRPr lang="en-US"/>
           </a:p>
@@ -4787,7 +4787,7 @@
           <a:p>
             <a:fld id="{5BCAD085-E8A6-8845-BD4E-CB4CCA059FC4}" type="datetimeFigureOut">
               <a:rPr lang="en-US" smtClean="0"/>
-              <a:t>1/18/2026</a:t>
+              <a:t>2/22/2026</a:t>
             </a:fld>
             <a:endParaRPr lang="en-US"/>
           </a:p>
@@ -4913,7 +4913,7 @@
           <a:p>
             <a:fld id="{5BCAD085-E8A6-8845-BD4E-CB4CCA059FC4}" type="datetimeFigureOut">
               <a:rPr lang="en-US" smtClean="0"/>
-              <a:t>1/18/2026</a:t>
+              <a:t>2/22/2026</a:t>
             </a:fld>
             <a:endParaRPr lang="en-US"/>
           </a:p>
@@ -5168,7 +5168,7 @@
           <a:p>
             <a:fld id="{5BCAD085-E8A6-8845-BD4E-CB4CCA059FC4}" type="datetimeFigureOut">
               <a:rPr lang="en-US" smtClean="0"/>
-              <a:t>1/18/2026</a:t>
+              <a:t>2/22/2026</a:t>
             </a:fld>
             <a:endParaRPr lang="en-US"/>
           </a:p>
@@ -5482,7 +5482,7 @@
           <a:p>
             <a:fld id="{5BCAD085-E8A6-8845-BD4E-CB4CCA059FC4}" type="datetimeFigureOut">
               <a:rPr lang="en-US" smtClean="0"/>
-              <a:t>1/18/2026</a:t>
+              <a:t>2/22/2026</a:t>
             </a:fld>
             <a:endParaRPr lang="en-US"/>
           </a:p>
@@ -5833,7 +5833,7 @@
           <a:p>
             <a:fld id="{5BCAD085-E8A6-8845-BD4E-CB4CCA059FC4}" type="datetimeFigureOut">
               <a:rPr lang="en-US" smtClean="0"/>
-              <a:t>1/18/2026</a:t>
+              <a:t>2/22/2026</a:t>
             </a:fld>
             <a:endParaRPr lang="en-US"/>
           </a:p>
@@ -7326,7 +7326,7 @@
           <a:graphicData uri="http://schemas.openxmlformats.org/presentationml/2006/ole">
             <mc:AlternateContent xmlns:mc="http://schemas.openxmlformats.org/markup-compatibility/2006">
               <mc:Choice xmlns:v="urn:schemas-microsoft-com:vml" Requires="v">
-                <p:oleObj spid="_x0000_s4101" name="Bitmap Image" r:id="rId4" imgW="708866" imgH="606790" progId="PBrush">
+                <p:oleObj spid="_x0000_s4104" name="Bitmap Image" r:id="rId4" imgW="708866" imgH="606790" progId="PBrush">
                   <p:embed/>
                 </p:oleObj>
               </mc:Choice>
@@ -9842,7 +9842,6 @@
               <a:rPr lang="en-GB" sz="11500" b="1" dirty="0"/>
               <a:t>Thank You</a:t>
             </a:r>
-            <a:endParaRPr lang="en-GB" sz="11500" b="1" dirty="0"/>
           </a:p>
         </p:txBody>
       </p:sp>

</xml_diff>